<commit_message>
feat: align Tableau HR Analytics project with Data With Baraa end-to-end tutorial
</commit_message>
<xml_diff>
--- a/assets/docs/Khairul_Raihan_Hidayat_Portfolio_Deck.pptx
+++ b/assets/docs/Khairul_Raihan_Hidayat_Portfolio_Deck.pptx
@@ -9693,7 +9693,7 @@
                 </a:solidFill>
                 <a:latin typeface="Segoe UI"/>
               </a:rPr>
-              <a:t>PROJECT 02: BUSINESS INTELLIGENCE</a:t>
+              <a:t>PROJECT 02: BUSINESS INTELLIGENCE &amp; TABLEAU</a:t>
             </a:r>
           </a:p>
         </p:txBody>
@@ -9741,7 +9741,7 @@
                 </a:solidFill>
                 <a:latin typeface="Segoe UI"/>
               </a:rPr>
-              <a:t>Tableau HR Analytics: Workforce &amp; Retention Dashboard</a:t>
+              <a:t>End-to-End HR Analytics: Workforce &amp; Retention Dashboard</a:t>
             </a:r>
           </a:p>
         </p:txBody>
@@ -9789,7 +9789,7 @@
                 </a:solidFill>
                 <a:latin typeface="Segoe UI"/>
               </a:rPr>
-              <a:t>Analisis komprehensif 8.950 catatan karyawan untuk mendeteksi tren retensi, kompensasi, dan performa.</a:t>
+              <a:t>Arsitektur BI dua perspektif (Summary &amp; Detailed Roster) dengan Figma Dark UI terinspirasi metodologi Data With Baraa.</a:t>
             </a:r>
           </a:p>
         </p:txBody>
@@ -9908,7 +9908,7 @@
                 </a:solidFill>
                 <a:latin typeface="Segoe UI"/>
               </a:rPr>
-              <a:t>Interactive Tableau Desktop Dashboard: Employee Retention, State Map &amp; Performance Scatter Plot.</a:t>
+              <a:t>Executive Summary Dashboard: BAN KPIs, Demographics Donut, Performance Heatmap &amp; Compensation Scatter Plot.</a:t>
             </a:r>
           </a:p>
         </p:txBody>
@@ -10030,7 +10030,7 @@
           <a:lstStyle/>
           <a:p>
             <a:pPr>
-              <a:defRPr sz="1600" b="1">
+              <a:defRPr sz="1500" b="1">
                 <a:solidFill>
                   <a:srgbClr val="0F2437"/>
                 </a:solidFill>
@@ -10038,7 +10038,7 @@
               </a:defRPr>
             </a:pPr>
             <a:r>
-              <a:rPr sz="1600" b="1">
+              <a:rPr sz="1500" b="1">
                 <a:solidFill>
                   <a:srgbClr val="0F2437"/>
                 </a:solidFill>
@@ -10047,7 +10047,7 @@
               <a:t>8.950  </a:t>
             </a:r>
             <a:r>
-              <a:rPr sz="950" b="1">
+              <a:rPr sz="900" b="1">
                 <a:solidFill>
                   <a:srgbClr val="2563EB"/>
                 </a:solidFill>
@@ -10064,7 +10064,7 @@
               <a:spcAft>
                 <a:spcPts val="300"/>
               </a:spcAft>
-              <a:defRPr sz="850" b="0" i="0">
+              <a:defRPr sz="800" b="0" i="0">
                 <a:solidFill>
                   <a:srgbClr val="475569"/>
                 </a:solidFill>
@@ -10072,13 +10072,13 @@
               </a:defRPr>
             </a:pPr>
             <a:r>
-              <a:rPr sz="850" b="0" i="0">
+              <a:rPr sz="800" b="0" i="0">
                 <a:solidFill>
                   <a:srgbClr val="475569"/>
                 </a:solidFill>
                 <a:latin typeface="Segoe UI"/>
               </a:rPr>
-              <a:t>Basis data tenaga kerja dianalisis</a:t>
+              <a:t>7.984 Karyawan Aktif &amp; 966 Terminasi</a:t>
             </a:r>
           </a:p>
         </p:txBody>
@@ -10153,7 +10153,7 @@
           <a:lstStyle/>
           <a:p>
             <a:pPr>
-              <a:defRPr sz="1600" b="1">
+              <a:defRPr sz="1500" b="1">
                 <a:solidFill>
                   <a:srgbClr val="0F2437"/>
                 </a:solidFill>
@@ -10161,7 +10161,7 @@
               </a:defRPr>
             </a:pPr>
             <a:r>
-              <a:rPr sz="1600" b="1">
+              <a:rPr sz="1500" b="1">
                 <a:solidFill>
                   <a:srgbClr val="0F2437"/>
                 </a:solidFill>
@@ -10170,7 +10170,7 @@
               <a:t>89.2%  </a:t>
             </a:r>
             <a:r>
-              <a:rPr sz="950" b="1">
+              <a:rPr sz="900" b="1">
                 <a:solidFill>
                   <a:srgbClr val="2563EB"/>
                 </a:solidFill>
@@ -10187,7 +10187,7 @@
               <a:spcAft>
                 <a:spcPts val="300"/>
               </a:spcAft>
-              <a:defRPr sz="850" b="0" i="0">
+              <a:defRPr sz="800" b="0" i="0">
                 <a:solidFill>
                   <a:srgbClr val="475569"/>
                 </a:solidFill>
@@ -10195,13 +10195,13 @@
               </a:defRPr>
             </a:pPr>
             <a:r>
-              <a:rPr sz="850" b="0" i="0">
+              <a:rPr sz="800" b="0" i="0">
                 <a:solidFill>
                   <a:srgbClr val="475569"/>
                 </a:solidFill>
                 <a:latin typeface="Segoe UI"/>
               </a:rPr>
-              <a:t>Tingkat loyalitas karyawan aktif</a:t>
+              <a:t>Tingkat loyalitas vs 10.8% turnover rate</a:t>
             </a:r>
           </a:p>
         </p:txBody>
@@ -10276,7 +10276,7 @@
           <a:lstStyle/>
           <a:p>
             <a:pPr>
-              <a:defRPr sz="1600" b="1">
+              <a:defRPr sz="1500" b="1">
                 <a:solidFill>
                   <a:srgbClr val="0F2437"/>
                 </a:solidFill>
@@ -10284,22 +10284,22 @@
               </a:defRPr>
             </a:pPr>
             <a:r>
-              <a:rPr sz="1600" b="1">
+              <a:rPr sz="1500" b="1">
                 <a:solidFill>
                   <a:srgbClr val="0F2437"/>
                 </a:solidFill>
                 <a:latin typeface="Segoe UI"/>
               </a:rPr>
-              <a:t>10.8%  </a:t>
-            </a:r>
-            <a:r>
-              <a:rPr sz="950" b="1">
+              <a:t>2 VIEWS  </a:t>
+            </a:r>
+            <a:r>
+              <a:rPr sz="900" b="1">
                 <a:solidFill>
                   <a:srgbClr val="2563EB"/>
                 </a:solidFill>
                 <a:latin typeface="Segoe UI"/>
               </a:rPr>
-              <a:t>— TURNOVER RATE</a:t>
+              <a:t>— DUAL DASHBOARD</a:t>
             </a:r>
           </a:p>
           <a:p>
@@ -10310,7 +10310,7 @@
               <a:spcAft>
                 <a:spcPts val="300"/>
               </a:spcAft>
-              <a:defRPr sz="850" b="0" i="0">
+              <a:defRPr sz="800" b="0" i="0">
                 <a:solidFill>
                   <a:srgbClr val="475569"/>
                 </a:solidFill>
@@ -10318,13 +10318,13 @@
               </a:defRPr>
             </a:pPr>
             <a:r>
-              <a:rPr sz="850" b="0" i="0">
+              <a:rPr sz="800" b="0" i="0">
                 <a:solidFill>
                   <a:srgbClr val="475569"/>
                 </a:solidFill>
                 <a:latin typeface="Segoe UI"/>
               </a:rPr>
-              <a:t>Tingkat atrisi teridentifikasi</a:t>
+              <a:t>Figma Dark UI &amp; Filterable Granular Roster</a:t>
             </a:r>
           </a:p>
         </p:txBody>
@@ -10337,8 +10337,8 @@
         </p:nvSpPr>
         <p:spPr>
           <a:xfrm>
-            <a:off x="7315200" y="4572000"/>
-            <a:ext cx="3931920" cy="1737360"/>
+            <a:off x="7315200" y="4526280"/>
+            <a:ext cx="3931920" cy="1783080"/>
           </a:xfrm>
           <a:prstGeom prst="rect">
             <a:avLst/>
@@ -10358,7 +10358,7 @@
               <a:spcAft>
                 <a:spcPts val="300"/>
               </a:spcAft>
-              <a:defRPr sz="1000" b="1" i="0">
+              <a:defRPr sz="950" b="1" i="0">
                 <a:solidFill>
                   <a:srgbClr val="0F2437"/>
                 </a:solidFill>
@@ -10366,88 +10366,137 @@
               </a:defRPr>
             </a:pPr>
             <a:r>
-              <a:rPr sz="1000" b="1" i="0">
+              <a:rPr sz="950" b="1" i="0">
                 <a:solidFill>
                   <a:srgbClr val="0F2437"/>
                 </a:solidFill>
                 <a:latin typeface="Segoe UI"/>
               </a:rPr>
-              <a:t>STRATEGIC HR INSIGHTS:</a:t>
-            </a:r>
-          </a:p>
-          <a:p>
-            <a:pPr algn="l">
-              <a:spcBef>
-                <a:spcPts val="0"/>
-              </a:spcBef>
-              <a:spcAft>
-                <a:spcPts val="300"/>
-              </a:spcAft>
-              <a:defRPr sz="850" b="0" i="0">
+              <a:t>FITUR TEKNIS &amp; STRATEGIS UTAMA:</a:t>
+            </a:r>
+          </a:p>
+          <a:p>
+            <a:pPr>
+              <a:spcAft>
+                <a:spcPts val="200"/>
+              </a:spcAft>
+              <a:defRPr sz="850" b="1">
+                <a:solidFill>
+                  <a:srgbClr val="2563EB"/>
+                </a:solidFill>
+                <a:latin typeface="Segoe UI"/>
+              </a:defRPr>
+            </a:pPr>
+            <a:r>
+              <a:rPr sz="850" b="1">
+                <a:solidFill>
+                  <a:srgbClr val="2563EB"/>
+                </a:solidFill>
+                <a:latin typeface="Segoe UI"/>
+              </a:rPr>
+              <a:t>• Arsitektur Dua Perspektif: </a:t>
+            </a:r>
+            <a:r>
+              <a:rPr sz="800" b="0">
                 <a:solidFill>
                   <a:srgbClr val="0F172A"/>
                 </a:solidFill>
                 <a:latin typeface="Segoe UI"/>
-              </a:defRPr>
-            </a:pPr>
-            <a:r>
-              <a:rPr sz="850" b="0" i="0">
+              </a:rPr>
+              <a:t>Executive Summary untuk metrik makro (demografi, retensi, kompensasi) dan Detailed Records untuk audit 8.950 baris karyawan.</a:t>
+            </a:r>
+          </a:p>
+          <a:p>
+            <a:pPr>
+              <a:spcAft>
+                <a:spcPts val="200"/>
+              </a:spcAft>
+              <a:defRPr sz="850" b="1">
+                <a:solidFill>
+                  <a:srgbClr val="2563EB"/>
+                </a:solidFill>
+                <a:latin typeface="Segoe UI"/>
+              </a:defRPr>
+            </a:pPr>
+            <a:r>
+              <a:rPr sz="850" b="1">
+                <a:solidFill>
+                  <a:srgbClr val="2563EB"/>
+                </a:solidFill>
+                <a:latin typeface="Segoe UI"/>
+              </a:rPr>
+              <a:t>• Calculated Fields &amp; LOD: </a:t>
+            </a:r>
+            <a:r>
+              <a:rPr sz="800" b="0">
                 <a:solidFill>
                   <a:srgbClr val="0F172A"/>
                 </a:solidFill>
                 <a:latin typeface="Segoe UI"/>
               </a:rPr>
-              <a:t>• Kompensasi vs Performa: Analisis scatter plot mengidentifikasi retensi talenta berkinerja tinggi rentan terhadap stagnasi gaji.</a:t>
-            </a:r>
-          </a:p>
-          <a:p>
-            <a:pPr algn="l">
-              <a:spcBef>
-                <a:spcPts val="0"/>
-              </a:spcBef>
-              <a:spcAft>
-                <a:spcPts val="300"/>
-              </a:spcAft>
-              <a:defRPr sz="850" b="0" i="0">
+              <a:t>Dual-axis donut (gender 54% M / 46% F), lollipop gaji per pendidikan, matriks performa, dan kalkulasi masa kerja (Length of Hire).</a:t>
+            </a:r>
+          </a:p>
+          <a:p>
+            <a:pPr>
+              <a:spcAft>
+                <a:spcPts val="200"/>
+              </a:spcAft>
+              <a:defRPr sz="850" b="1">
+                <a:solidFill>
+                  <a:srgbClr val="2563EB"/>
+                </a:solidFill>
+                <a:latin typeface="Segoe UI"/>
+              </a:defRPr>
+            </a:pPr>
+            <a:r>
+              <a:rPr sz="850" b="1">
+                <a:solidFill>
+                  <a:srgbClr val="2563EB"/>
+                </a:solidFill>
+                <a:latin typeface="Segoe UI"/>
+              </a:rPr>
+              <a:t>• Divisional Turnover Insights: </a:t>
+            </a:r>
+            <a:r>
+              <a:rPr sz="800" b="0">
                 <a:solidFill>
                   <a:srgbClr val="0F172A"/>
                 </a:solidFill>
                 <a:latin typeface="Segoe UI"/>
-              </a:defRPr>
-            </a:pPr>
-            <a:r>
-              <a:rPr sz="850" b="0" i="0">
+              </a:rPr>
+              <a:t>Divisi Operations (2.429 staf) dan Sales (1.634) menyumbang turnover tertinggi; scatter plot gaji memetakan disparitas peran manajemen vs staf.</a:t>
+            </a:r>
+          </a:p>
+          <a:p>
+            <a:pPr>
+              <a:spcAft>
+                <a:spcPts val="200"/>
+              </a:spcAft>
+              <a:defRPr sz="850" b="1">
+                <a:solidFill>
+                  <a:srgbClr val="2563EB"/>
+                </a:solidFill>
+                <a:latin typeface="Segoe UI"/>
+              </a:defRPr>
+            </a:pPr>
+            <a:r>
+              <a:rPr sz="850" b="1">
+                <a:solidFill>
+                  <a:srgbClr val="2563EB"/>
+                </a:solidFill>
+                <a:latin typeface="Segoe UI"/>
+              </a:rPr>
+              <a:t>• Framework End-to-End: </a:t>
+            </a:r>
+            <a:r>
+              <a:rPr sz="800" b="0">
                 <a:solidFill>
                   <a:srgbClr val="0F172A"/>
                 </a:solidFill>
                 <a:latin typeface="Segoe UI"/>
               </a:rPr>
-              <a:t>• Geographic Mapping: Visualisasi sebaran kantor cabang membantu pemerataan beban kerja dan perencanaan tunjangan regional.</a:t>
-            </a:r>
-          </a:p>
-          <a:p>
-            <a:pPr algn="l">
-              <a:spcBef>
-                <a:spcPts val="0"/>
-              </a:spcBef>
-              <a:spcAft>
-                <a:spcPts val="300"/>
-              </a:spcAft>
-              <a:defRPr sz="850" b="0" i="0">
-                <a:solidFill>
-                  <a:srgbClr val="0F172A"/>
-                </a:solidFill>
-                <a:latin typeface="Segoe UI"/>
-              </a:defRPr>
-            </a:pPr>
-            <a:r>
-              <a:rPr sz="850" b="0" i="0">
-                <a:solidFill>
-                  <a:srgbClr val="0F172A"/>
-                </a:solidFill>
-                <a:latin typeface="Segoe UI"/>
-              </a:rPr>
-              <a:t>• Rekomendasi Kebijakan: Penyesuaian skema review performa semesteran untuk memitigasi turnover pada divisi berisiko tinggi.</a:t>
+              <a:t>Diadopsi dari kurikulum profesional Data With Baraa (Complete HR Tableau Project End-to-End) memadukan Figma Dark UI &amp; Tableau.</a:t>
             </a:r>
           </a:p>
         </p:txBody>

</xml_diff>